<commit_message>
added code for the beyond SARCASTIC project
</commit_message>
<xml_diff>
--- a/beyond SARCASTIC.pptx
+++ b/beyond SARCASTIC.pptx
@@ -5314,7 +5314,7 @@
                 <a:ea typeface="Calibri" pitchFamily="34" charset="-122"/>
                 <a:cs typeface="Calibri" pitchFamily="34" charset="-120"/>
               </a:rPr>
-              <a:t>Trihedral = orientation-insensitive, maximum-RCS calibration standard.</a:t>
+              <a:t>Trihedral = orientation-insensitive, maximum-cross section calibration standard.</a:t>
             </a:r>
             <a:endParaRPr lang="en-US" sz="1300" dirty="0"/>
           </a:p>
@@ -7657,7 +7657,7 @@
                 <a:ea typeface="Cambria" pitchFamily="34" charset="-122"/>
                 <a:cs typeface="Cambria" pitchFamily="34" charset="-120"/>
               </a:rPr>
-              <a:t>SAR → GMTI: a new architecture axis, not a scatterer type</a:t>
+              <a:t>SAR → Ground Moving Target Interval (GMTI): a new architecture axis, not a scatterer type</a:t>
             </a:r>
             <a:endParaRPr lang="en-US" sz="2300" dirty="0"/>
           </a:p>
@@ -7727,7 +7727,7 @@
                 <a:ea typeface="Calibri" pitchFamily="34" charset="-122"/>
                 <a:cs typeface="Calibri" pitchFamily="34" charset="-120"/>
               </a:rPr>
-              <a:t>Clutter cancellation (DPCA, or STAP for non-ideal clutter) separates movers from stationary background across channels -- a genuinely different processing chain from Step 7’s single-channel image formation, not a variant of it</a:t>
+              <a:t>Clutter cancellation separates movers from stationary background across channels -- a genuinely different processing chain from Step 7’s single-channel image formation, not a variant of it</a:t>
             </a:r>
             <a:endParaRPr lang="en-US" sz="1400" dirty="0"/>
           </a:p>
@@ -7777,6 +7777,29 @@
               </a:rPr>
               <a:t>Output is detections/tracks (range, azimuth, radial velocity) per contact, not an image</a:t>
             </a:r>
+          </a:p>
+          <a:p>
+            <a:pPr marL="203200" indent="-203200">
+              <a:lnSpc>
+                <a:spcPct val="112000"/>
+              </a:lnSpc>
+              <a:spcAft>
+                <a:spcPts val="1200"/>
+              </a:spcAft>
+              <a:buSzPct val="100000"/>
+              <a:buChar char="•"/>
+            </a:pPr>
+            <a:r>
+              <a:rPr lang="en-US" sz="1400" dirty="0">
+                <a:solidFill>
+                  <a:srgbClr val="141A22"/>
+                </a:solidFill>
+                <a:latin typeface="Calibri" pitchFamily="34" charset="0"/>
+                <a:ea typeface="Calibri" pitchFamily="34" charset="-122"/>
+                <a:cs typeface="Calibri" pitchFamily="34" charset="-120"/>
+              </a:rPr>
+              <a:t>Simulated world updates at radar slow-time rate, NOT compute rate</a:t>
+            </a:r>
             <a:endParaRPr lang="en-US" sz="1400" dirty="0"/>
           </a:p>
         </p:txBody>
@@ -7857,7 +7880,7 @@
                 <a:ea typeface="Calibri" pitchFamily="34" charset="-122"/>
                 <a:cs typeface="Calibri" pitchFamily="34" charset="-120"/>
               </a:rPr>
-              <a:t>drive multi-actor scenes with the engine’s own nav-mesh/crowd/traffic AI instead of hand-scripting tracks. Bake each actor’s trajectory once (position + heading vs. time), then replay it decoupled from the engine’s render tick -- a CPI can be well under a second of slow-time, faster than the nav-mesh update rate.</a:t>
+              <a:t>drive multi-actor scenes with the engine’s own nav-mesh/crowd/traffic AI instead of hand-scripting tracks. Bake each actor’s trajectory once (position + heading vs. time), then replay it decoupled from the engine’s render tick -- a coherent processing interval can be well under a second of slow-time, faster than the nav-mesh update rate.</a:t>
             </a:r>
             <a:endParaRPr lang="en-US" sz="1300" dirty="0"/>
           </a:p>
@@ -9352,7 +9375,13 @@
           <p:cNvGraphicFramePr>
             <a:graphicFrameLocks noGrp="1"/>
           </p:cNvGraphicFramePr>
-          <p:nvPr/>
+          <p:nvPr>
+            <p:extLst>
+              <p:ext uri="{D42A27DB-BD31-4B8C-83A1-F6EECF244321}">
+                <p14:modId xmlns:p14="http://schemas.microsoft.com/office/powerpoint/2010/main" val="993355251"/>
+              </p:ext>
+            </p:extLst>
+          </p:nvPr>
         </p:nvGraphicFramePr>
         <p:xfrm>
           <a:off x="457200" y="1828800"/>
@@ -9893,7 +9922,7 @@
                           <a:ea typeface="Calibri" pitchFamily="34" charset="-122"/>
                           <a:cs typeface="Calibri" pitchFamily="34" charset="-120"/>
                         </a:rPr>
-                        <a:t>Peak RCS, null depth, sidelobe level, and mainlobe width all match theory</a:t>
+                        <a:t>Peak radar cross section (RCS), null depth, sidelobe level, and mainlobe width all match theory</a:t>
                       </a:r>
                       <a:endParaRPr lang="en-US" sz="950" dirty="0">
                         <a:latin typeface="Calibri" charset="0"/>
@@ -10172,7 +10201,7 @@
                           <a:ea typeface="Calibri" pitchFamily="34" charset="-122"/>
                           <a:cs typeface="Calibri" pitchFamily="34" charset="-120"/>
                         </a:rPr>
-                        <a:t>SSIM ≥ 0.95 (typical) and RMS error below threshold inside the sector; both degrade sharply together just outside it</a:t>
+                        <a:t>Structural Similarity Matix ≥ 0.95 (typical) and root mean square (RMS) error below threshold inside the sector; both degrade sharply together just outside it</a:t>
                       </a:r>
                       <a:endParaRPr lang="en-US" sz="950" dirty="0">
                         <a:latin typeface="Calibri" charset="0"/>
@@ -10315,7 +10344,7 @@
                           <a:ea typeface="Calibri" pitchFamily="34" charset="-122"/>
                           <a:cs typeface="Calibri" pitchFamily="34" charset="-120"/>
                         </a:rPr>
-                        <a:t>Extract (x_k,y_k[,z_k]) from simulated phase history via CLEAN/matrix-pencil as if unknown; transform aperture-relative → world coords; compare to CAD mesh</a:t>
+                        <a:t>Extract (x_k,y_k[,z_k]) from simulated phase history via CLEAN/matrix-pencil as if unknown; transform aperture-relative → world coords; compare to rendering mesh</a:t>
                       </a:r>
                       <a:endParaRPr lang="en-US" sz="950" dirty="0">
                         <a:latin typeface="Calibri" charset="0"/>
@@ -22530,22 +22559,7 @@
                 <a:ea typeface="Calibri" pitchFamily="34" charset="-122"/>
                 <a:cs typeface="Calibri" pitchFamily="34" charset="-120"/>
               </a:rPr>
-              <a:t>Ansys Perceive EM/SBR+ already does dense multi-bounce ray tracing with per-bounce polarimetric materials, plus PTD/</a:t>
-            </a:r>
-            <a:r>
-              <a:rPr lang="en-US" sz="1400" dirty="0"/>
-              <a:t> Uniform Theory of Diffraction  (</a:t>
-            </a:r>
-            <a:r>
-              <a:rPr lang="en-US" sz="1400" dirty="0">
-                <a:solidFill>
-                  <a:srgbClr val="141A22"/>
-                </a:solidFill>
-                <a:latin typeface="Calibri" pitchFamily="34" charset="0"/>
-                <a:ea typeface="Calibri" pitchFamily="34" charset="-122"/>
-                <a:cs typeface="Calibri" pitchFamily="34" charset="-120"/>
-              </a:rPr>
-              <a:t>UTD) diffraction and creeping waves. That’s a mature, commercial, full-featured solver -- </a:t>
+              <a:t>Ansys Perceive EM/SBR+ already does dense multi-bounce ray tracing with per-bounce polarimetric materials, plus PTD/UTD diffraction and creeping waves. That’s a mature, commercial, full-featured solver -- </a:t>
             </a:r>
             <a:r>
               <a:rPr lang="en-US" sz="1400" b="1" dirty="0">
@@ -22694,7 +22708,7 @@
                 <a:ea typeface="Calibri" pitchFamily="34" charset="-122"/>
                 <a:cs typeface="Calibri" pitchFamily="34" charset="-120"/>
               </a:rPr>
-              <a:t>The win only shows up at scale (a full phase history, an ATR training sweep, a Ground Moving Target Indicator channel set) -- not for a single one-off look</a:t>
+              <a:t>The win only shows up at scale -- not for a single one-off look</a:t>
             </a:r>
             <a:endParaRPr lang="en-US" sz="1250" dirty="0"/>
           </a:p>
@@ -23370,7 +23384,7 @@
                 <a:ea typeface="Calibri" pitchFamily="34" charset="-122"/>
                 <a:cs typeface="Calibri" pitchFamily="34" charset="-120"/>
               </a:rPr>
-              <a:t>Same sensor mode / resolution (2m GSD, real TerraSAR-X Spotlight) at every scale -- what changes is the footprint, so pulse count scales with it. n* = number of collects before ASC-cached total cost undercuts Ansys.</a:t>
+              <a:t>Same sensor mode / resolution (2m Ground Sample Distance (GSD), real TerraSAR-X Spotlight) at every scale -- what changes is the footprint, so pulse count scales with it. n* = number of collects before ASC-cached total cost undercuts Ansys.</a:t>
             </a:r>
             <a:endParaRPr lang="en-US" sz="1200" dirty="0"/>
           </a:p>
@@ -23508,7 +23522,7 @@
                 <a:ea typeface="Calibri" pitchFamily="34" charset="-122"/>
                 <a:cs typeface="Calibri" pitchFamily="34" charset="-120"/>
               </a:rPr>
-              <a:t>4m trihedral (N=1): n*=844 collects -- a one-off cal target essentially never pays back on its own</a:t>
+              <a:t>4m^2 trihedral (N=1): n*=844 collects -- a one-off cal target essentially never pays back on its own</a:t>
             </a:r>
             <a:endParaRPr lang="en-US" sz="1200" dirty="0"/>
           </a:p>
@@ -23630,7 +23644,7 @@
         <p:spPr>
           <a:xfrm>
             <a:off x="905256" y="6151234"/>
-            <a:ext cx="8336280" cy="276999"/>
+            <a:ext cx="5526024" cy="461665"/>
           </a:xfrm>
           <a:prstGeom prst="rect">
             <a:avLst/>
@@ -23645,7 +23659,7 @@
           <a:p>
             <a:r>
               <a:rPr lang="en-US" sz="1200" i="1" dirty="0"/>
-              <a:t>*Both approaches measured on the same single desktop/laptop-class GPU, not a cluster</a:t>
+              <a:t>*Both approaches estimated on the same single desktop/laptop-class Graphics Processing Unit (GPU), not a cluster</a:t>
             </a:r>
           </a:p>
         </p:txBody>
@@ -24001,7 +24015,32 @@
                 <a:ea typeface="Calibri" pitchFamily="34" charset="-122"/>
                 <a:cs typeface="Calibri" pitchFamily="34" charset="-120"/>
               </a:rPr>
-              <a:t>Full city (100km²): 54s ASC-cached vs. 1.88hr Ansys SBR+ -- 125x</a:t>
+              <a:t>Full city (100km²): </a:t>
+            </a:r>
+            <a:r>
+              <a:rPr lang="en-US" sz="1150" dirty="0">
+                <a:solidFill>
+                  <a:srgbClr val="141A22"/>
+                </a:solidFill>
+                <a:highlight>
+                  <a:srgbClr val="FFFF00"/>
+                </a:highlight>
+                <a:latin typeface="Calibri" pitchFamily="34" charset="0"/>
+                <a:ea typeface="Calibri" pitchFamily="34" charset="-122"/>
+                <a:cs typeface="Calibri" pitchFamily="34" charset="-120"/>
+              </a:rPr>
+              <a:t>54s</a:t>
+            </a:r>
+            <a:r>
+              <a:rPr lang="en-US" sz="1150" dirty="0">
+                <a:solidFill>
+                  <a:srgbClr val="141A22"/>
+                </a:solidFill>
+                <a:latin typeface="Calibri" pitchFamily="34" charset="0"/>
+                <a:ea typeface="Calibri" pitchFamily="34" charset="-122"/>
+                <a:cs typeface="Calibri" pitchFamily="34" charset="-120"/>
+              </a:rPr>
+              <a:t> ASC-cached vs. 1.88hr Ansys SBR+ -- 125x</a:t>
             </a:r>
             <a:endParaRPr lang="en-US" sz="1150" dirty="0"/>
           </a:p>

</xml_diff>